<commit_message>
fix: pitch deck contrast — Slide 3 + 10 body text now readable
- Slide 3 (Solution): card body text C.lightgray → C.bodytext (#334155)
- Slide 10 (Vision): timeline items C.lightgray → C.darktext
- Security flow step bodies: C.lightgray → C.offwhite, font 7.5→8
- Regenerated PPTX + PDF + slide images
</commit_message>
<xml_diff>
--- a/PITCH_DECK_STELLARNEST_APAC2026.pptx
+++ b/PITCH_DECK_STELLARNEST_APAC2026.pptx
@@ -2818,7 +2818,7 @@
             <a:r>
               <a:rPr lang="en-US" sz="900" dirty="0">
                 <a:solidFill>
-                  <a:srgbClr val="E2E8F0"/>
+                  <a:srgbClr val="1E293B"/>
                 </a:solidFill>
               </a:rPr>
               <a:t>✅ USDC testnet live</a:t>
@@ -2890,7 +2890,7 @@
             <a:r>
               <a:rPr lang="en-US" sz="900" dirty="0">
                 <a:solidFill>
-                  <a:srgbClr val="E2E8F0"/>
+                  <a:srgbClr val="1E293B"/>
                 </a:solidFill>
               </a:rPr>
               <a:t>✅ Magic Claim Links</a:t>
@@ -2962,7 +2962,7 @@
             <a:r>
               <a:rPr lang="en-US" sz="900" dirty="0">
                 <a:solidFill>
-                  <a:srgbClr val="E2E8F0"/>
+                  <a:srgbClr val="1E293B"/>
                 </a:solidFill>
               </a:rPr>
               <a:t>✅ 70/30 Split-Routing</a:t>
@@ -3034,7 +3034,7 @@
             <a:r>
               <a:rPr lang="en-US" sz="900" dirty="0">
                 <a:solidFill>
-                  <a:srgbClr val="E2E8F0"/>
+                  <a:srgbClr val="1E293B"/>
                 </a:solidFill>
               </a:rPr>
               <a:t>✅ 6 ASEAN corridors</a:t>
@@ -3106,7 +3106,7 @@
             <a:r>
               <a:rPr lang="en-US" sz="900" dirty="0">
                 <a:solidFill>
-                  <a:srgbClr val="E2E8F0"/>
+                  <a:srgbClr val="1E293B"/>
                 </a:solidFill>
               </a:rPr>
               <a:t>✅ Demo mode ($2,650 YTD)</a:t>
@@ -3337,7 +3337,7 @@
             <a:r>
               <a:rPr lang="en-US" sz="900" dirty="0">
                 <a:solidFill>
-                  <a:srgbClr val="E2E8F0"/>
+                  <a:srgbClr val="1E293B"/>
                 </a:solidFill>
               </a:rPr>
               <a:t>🏦 6 corridors live</a:t>
@@ -3409,7 +3409,7 @@
             <a:r>
               <a:rPr lang="en-US" sz="900" dirty="0">
                 <a:solidFill>
-                  <a:srgbClr val="E2E8F0"/>
+                  <a:srgbClr val="1E293B"/>
                 </a:solidFill>
               </a:rPr>
               <a:t>🏦 Flip, Sakto, VietinBank anchors</a:t>
@@ -3481,7 +3481,7 @@
             <a:r>
               <a:rPr lang="en-US" sz="900" dirty="0">
                 <a:solidFill>
-                  <a:srgbClr val="E2E8F0"/>
+                  <a:srgbClr val="1E293B"/>
                 </a:solidFill>
               </a:rPr>
               <a:t>📄 Proof of Income API</a:t>
@@ -3553,7 +3553,7 @@
             <a:r>
               <a:rPr lang="en-US" sz="900" dirty="0">
                 <a:solidFill>
-                  <a:srgbClr val="E2E8F0"/>
+                  <a:srgbClr val="1E293B"/>
                 </a:solidFill>
               </a:rPr>
               <a:t>🔐 Security audit (Trail of Bits)</a:t>
@@ -3625,7 +3625,7 @@
             <a:r>
               <a:rPr lang="en-US" sz="900" dirty="0">
                 <a:solidFill>
-                  <a:srgbClr val="E2E8F0"/>
+                  <a:srgbClr val="1E293B"/>
                 </a:solidFill>
               </a:rPr>
               <a:t>📱 React Native mobile app</a:t>
@@ -3856,7 +3856,7 @@
             <a:r>
               <a:rPr lang="en-US" sz="900" dirty="0">
                 <a:solidFill>
-                  <a:srgbClr val="E2E8F0"/>
+                  <a:srgbClr val="1E293B"/>
                 </a:solidFill>
               </a:rPr>
               <a:t>🤝 2 bank partners (BCA, BRI)</a:t>
@@ -3928,7 +3928,7 @@
             <a:r>
               <a:rPr lang="en-US" sz="900" dirty="0">
                 <a:solidFill>
-                  <a:srgbClr val="E2E8F0"/>
+                  <a:srgbClr val="1E293B"/>
                 </a:solidFill>
               </a:rPr>
               <a:t>💰 Loan origination beta</a:t>
@@ -4000,7 +4000,7 @@
             <a:r>
               <a:rPr lang="en-US" sz="900" dirty="0">
                 <a:solidFill>
-                  <a:srgbClr val="E2E8F0"/>
+                  <a:srgbClr val="1E293B"/>
                 </a:solidFill>
               </a:rPr>
               <a:t>🌏 Thailand + Malaysia live</a:t>
@@ -4072,7 +4072,7 @@
             <a:r>
               <a:rPr lang="en-US" sz="900" dirty="0">
                 <a:solidFill>
-                  <a:srgbClr val="E2E8F0"/>
+                  <a:srgbClr val="1E293B"/>
                 </a:solidFill>
               </a:rPr>
               <a:t>📊 Income API v2.0</a:t>
@@ -4144,7 +4144,7 @@
             <a:r>
               <a:rPr lang="en-US" sz="900" dirty="0">
                 <a:solidFill>
-                  <a:srgbClr val="E2E8F0"/>
+                  <a:srgbClr val="1E293B"/>
                 </a:solidFill>
               </a:rPr>
               <a:t>🏦 5 more bank partners</a:t>
@@ -4375,7 +4375,7 @@
             <a:r>
               <a:rPr lang="en-US" sz="900" dirty="0">
                 <a:solidFill>
-                  <a:srgbClr val="E2E8F0"/>
+                  <a:srgbClr val="1E293B"/>
                 </a:solidFill>
               </a:rPr>
               <a:t>🌍 10+ countries, 20+ corridors</a:t>
@@ -4447,7 +4447,7 @@
             <a:r>
               <a:rPr lang="en-US" sz="900" dirty="0">
                 <a:solidFill>
-                  <a:srgbClr val="E2E8F0"/>
+                  <a:srgbClr val="1E293B"/>
                 </a:solidFill>
               </a:rPr>
               <a:t>💰 $5M+ ARR</a:t>
@@ -4519,7 +4519,7 @@
             <a:r>
               <a:rPr lang="en-US" sz="900" dirty="0">
                 <a:solidFill>
-                  <a:srgbClr val="E2E8F0"/>
+                  <a:srgbClr val="1E293B"/>
                 </a:solidFill>
               </a:rPr>
               <a:t>🏦 Central bank DSP integration</a:t>
@@ -4591,7 +4591,7 @@
             <a:r>
               <a:rPr lang="en-US" sz="900" dirty="0">
                 <a:solidFill>
-                  <a:srgbClr val="E2E8F0"/>
+                  <a:srgbClr val="1E293B"/>
                 </a:solidFill>
               </a:rPr>
               <a:t>🚀 1M+ active users</a:t>
@@ -4663,7 +4663,7 @@
             <a:r>
               <a:rPr lang="en-US" sz="900" dirty="0">
                 <a:solidFill>
-                  <a:srgbClr val="E2E8F0"/>
+                  <a:srgbClr val="1E293B"/>
                 </a:solidFill>
               </a:rPr>
               <a:t>💱 SEP-24/31 native support</a:t>
@@ -6480,7 +6480,7 @@
             <a:r>
               <a:rPr lang="en-US" sz="1000" dirty="0">
                 <a:solidFill>
-                  <a:srgbClr val="E2E8F0"/>
+                  <a:srgbClr val="334155"/>
                 </a:solidFill>
               </a:rPr>
               <a:t>Shareable payment URLs via WhatsApp or SMS. Recipient claims with just a phone number — no app, no wallet, no onboarding.</a:t>
@@ -6645,7 +6645,7 @@
             <a:r>
               <a:rPr lang="en-US" sz="1000" dirty="0">
                 <a:solidFill>
-                  <a:srgbClr val="E2E8F0"/>
+                  <a:srgbClr val="334155"/>
                 </a:solidFill>
               </a:rPr>
               <a:t>Every payment is automatically split: 70% to family, 30% to savings — enforced at the protocol level on the Stellar ledger.</a:t>
@@ -6810,7 +6810,7 @@
             <a:r>
               <a:rPr lang="en-US" sz="1000" dirty="0">
                 <a:solidFill>
-                  <a:srgbClr val="E2E8F0"/>
+                  <a:srgbClr val="334155"/>
                 </a:solidFill>
               </a:rPr>
               <a:t>BI-FAST, InstaPay, VietQR, PromptPay, DuitNow, PayNow — 6 ASEAN corridors with local settlement networks.</a:t>
@@ -14646,14 +14646,14 @@
               <a:buNone/>
             </a:pPr>
             <a:r>
-              <a:rPr lang="en-US" sz="750" dirty="0">
-                <a:solidFill>
-                  <a:srgbClr val="E2E8F0"/>
+              <a:rPr lang="en-US" sz="800" dirty="0">
+                <a:solidFill>
+                  <a:srgbClr val="F1F5F9"/>
                 </a:solidFill>
               </a:rPr>
               <a:t>Anonymous Auth gives each user a unique, stable UID.</a:t>
             </a:r>
-            <a:endParaRPr lang="en-US" sz="750" dirty="0"/>
+            <a:endParaRPr lang="en-US" sz="800" dirty="0"/>
           </a:p>
         </p:txBody>
       </p:sp>
@@ -14917,14 +14917,14 @@
               <a:buNone/>
             </a:pPr>
             <a:r>
-              <a:rPr lang="en-US" sz="750" dirty="0">
-                <a:solidFill>
-                  <a:srgbClr val="E2E8F0"/>
+              <a:rPr lang="en-US" sz="800" dirty="0">
+                <a:solidFill>
+                  <a:srgbClr val="F1F5F9"/>
                 </a:solidFill>
               </a:rPr>
               <a:t>UID + 100,000 rounds SHA-256 → 256-bit AES key.</a:t>
             </a:r>
-            <a:endParaRPr lang="en-US" sz="750" dirty="0"/>
+            <a:endParaRPr lang="en-US" sz="800" dirty="0"/>
           </a:p>
         </p:txBody>
       </p:sp>
@@ -15188,14 +15188,14 @@
               <a:buNone/>
             </a:pPr>
             <a:r>
-              <a:rPr lang="en-US" sz="750" dirty="0">
-                <a:solidFill>
-                  <a:srgbClr val="E2E8F0"/>
+              <a:rPr lang="en-US" sz="800" dirty="0">
+                <a:solidFill>
+                  <a:srgbClr val="F1F5F9"/>
                 </a:solidFill>
               </a:rPr>
               <a:t>Random IV per operation. Authenticated encryption.</a:t>
             </a:r>
-            <a:endParaRPr lang="en-US" sz="750" dirty="0"/>
+            <a:endParaRPr lang="en-US" sz="800" dirty="0"/>
           </a:p>
         </p:txBody>
       </p:sp>
@@ -15459,14 +15459,14 @@
               <a:buNone/>
             </a:pPr>
             <a:r>
-              <a:rPr lang="en-US" sz="750" dirty="0">
-                <a:solidFill>
-                  <a:srgbClr val="E2E8F0"/>
+              <a:rPr lang="en-US" sz="800" dirty="0">
+                <a:solidFill>
+                  <a:srgbClr val="F1F5F9"/>
                 </a:solidFill>
               </a:rPr>
               <a:t>base64(salt[16] || ct || iv[12]) stored as encryptedSecret.</a:t>
             </a:r>
-            <a:endParaRPr lang="en-US" sz="750" dirty="0"/>
+            <a:endParaRPr lang="en-US" sz="800" dirty="0"/>
           </a:p>
         </p:txBody>
       </p:sp>
@@ -15730,14 +15730,14 @@
               <a:buNone/>
             </a:pPr>
             <a:r>
-              <a:rPr lang="en-US" sz="750" dirty="0">
-                <a:solidFill>
-                  <a:srgbClr val="E2E8F0"/>
+              <a:rPr lang="en-US" sz="800" dirty="0">
+                <a:solidFill>
+                  <a:srgbClr val="F1F5F9"/>
                 </a:solidFill>
               </a:rPr>
               <a:t>Decrypted secret lives in walletSecretRef (React useRef). Never serialized.</a:t>
             </a:r>
-            <a:endParaRPr lang="en-US" sz="750" dirty="0"/>
+            <a:endParaRPr lang="en-US" sz="800" dirty="0"/>
           </a:p>
         </p:txBody>
       </p:sp>

</xml_diff>